<commit_message>
docs(deck): team Trident and members on title and closing slides
Co-Authored-By: Claude Opus 5.5 <noreply@anthropic.com>
</commit_message>
<xml_diff>
--- a/docs/deck/Radahn.pptx
+++ b/docs/deck/Radahn.pptx
@@ -4779,7 +4779,85 @@
         </p:nvSpPr>
         <p:spPr>
           <a:xfrm>
-            <a:off x="685800" y="6172200"/>
+            <a:off x="685800" y="5440680"/>
+            <a:ext cx="5120640" cy="365760"/>
+          </a:xfrm>
+          <a:prstGeom prst="rect">
+            <a:avLst/>
+          </a:prstGeom>
+          <a:noFill/>
+        </p:spPr>
+        <p:txBody>
+          <a:bodyPr wrap="square" anchor="t" lIns="0" rIns="0" tIns="0" bIns="0">
+            <a:spAutoFit/>
+          </a:bodyPr>
+          <a:lstStyle/>
+          <a:p>
+            <a:pPr algn="l">
+              <a:lnSpc>
+                <a:spcPct val="115000"/>
+              </a:lnSpc>
+            </a:pPr>
+            <a:r>
+              <a:rPr sz="1800" b="1" i="0">
+                <a:solidFill>
+                  <a:srgbClr val="EDE6D6"/>
+                </a:solidFill>
+                <a:latin typeface="Segoe UI"/>
+              </a:rPr>
+              <a:t>Team Trident</a:t>
+            </a:r>
+          </a:p>
+        </p:txBody>
+      </p:sp>
+      <p:sp>
+        <p:nvSpPr>
+          <p:cNvPr id="17" name="TextBox 16"/>
+          <p:cNvSpPr txBox="1"/>
+          <p:nvPr/>
+        </p:nvSpPr>
+        <p:spPr>
+          <a:xfrm>
+            <a:off x="685800" y="5806440"/>
+            <a:ext cx="5120640" cy="320040"/>
+          </a:xfrm>
+          <a:prstGeom prst="rect">
+            <a:avLst/>
+          </a:prstGeom>
+          <a:noFill/>
+        </p:spPr>
+        <p:txBody>
+          <a:bodyPr wrap="square" anchor="t" lIns="0" rIns="0" tIns="0" bIns="0">
+            <a:spAutoFit/>
+          </a:bodyPr>
+          <a:lstStyle/>
+          <a:p>
+            <a:pPr algn="l">
+              <a:lnSpc>
+                <a:spcPct val="115000"/>
+              </a:lnSpc>
+            </a:pPr>
+            <a:r>
+              <a:rPr sz="1400" b="0" i="0">
+                <a:solidFill>
+                  <a:srgbClr val="B8B1A2"/>
+                </a:solidFill>
+                <a:latin typeface="Segoe UI"/>
+              </a:rPr>
+              <a:t>Vaibhav Chauhan  ·  Akash Biswas  ·  Madhura Saravade</a:t>
+            </a:r>
+          </a:p>
+        </p:txBody>
+      </p:sp>
+      <p:sp>
+        <p:nvSpPr>
+          <p:cNvPr id="18" name="TextBox 17"/>
+          <p:cNvSpPr txBox="1"/>
+          <p:nvPr/>
+        </p:nvSpPr>
+        <p:spPr>
+          <a:xfrm>
+            <a:off x="685800" y="6217920"/>
             <a:ext cx="6400800" cy="274320"/>
           </a:xfrm>
           <a:prstGeom prst="rect">
@@ -4805,14 +4883,14 @@
                 </a:solidFill>
                 <a:latin typeface="Consolas"/>
               </a:rPr>
-              <a:t>Submitted to UNCHARTED 2026  ·  Agentic Memory track</a:t>
-            </a:r>
-          </a:p>
-        </p:txBody>
-      </p:sp>
-      <p:sp>
-        <p:nvSpPr>
-          <p:cNvPr id="17" name="Rounded Rectangle 16"/>
+              <a:t>UNCHARTED HACKATHON  ·  NEXUS</a:t>
+            </a:r>
+          </a:p>
+        </p:txBody>
+      </p:sp>
+      <p:sp>
+        <p:nvSpPr>
+          <p:cNvPr id="19" name="Rounded Rectangle 18"/>
           <p:cNvSpPr/>
           <p:nvPr/>
         </p:nvSpPr>
@@ -4860,7 +4938,7 @@
       </p:sp>
       <p:pic>
         <p:nvPicPr>
-          <p:cNvPr id="18" name="Picture 17" descr="shot-1-chat-used.png"/>
+          <p:cNvPr id="20" name="Picture 19" descr="full.png"/>
           <p:cNvPicPr>
             <a:picLocks noChangeAspect="1"/>
           </p:cNvPicPr>
@@ -6240,8 +6318,8 @@
         </p:nvSpPr>
         <p:spPr>
           <a:xfrm>
-            <a:off x="640080" y="5715000"/>
-            <a:ext cx="7315200" cy="411480"/>
+            <a:off x="640080" y="5440680"/>
+            <a:ext cx="7315200" cy="365760"/>
           </a:xfrm>
           <a:prstGeom prst="rect">
             <a:avLst/>
@@ -6277,21 +6355,60 @@
               </a:rPr>
               <a:t>radahn-ai.vercel.app</a:t>
             </a:r>
-            <a:r>
-              <a:rPr sz="1700" b="0" i="0">
+          </a:p>
+        </p:txBody>
+      </p:sp>
+      <p:sp>
+        <p:nvSpPr>
+          <p:cNvPr id="34" name="TextBox 33"/>
+          <p:cNvSpPr txBox="1"/>
+          <p:nvPr/>
+        </p:nvSpPr>
+        <p:spPr>
+          <a:xfrm>
+            <a:off x="640080" y="5870448"/>
+            <a:ext cx="10881360" cy="365760"/>
+          </a:xfrm>
+          <a:prstGeom prst="rect">
+            <a:avLst/>
+          </a:prstGeom>
+          <a:noFill/>
+        </p:spPr>
+        <p:txBody>
+          <a:bodyPr wrap="square" anchor="t" lIns="0" rIns="0" tIns="0" bIns="0">
+            <a:spAutoFit/>
+          </a:bodyPr>
+          <a:lstStyle/>
+          <a:p>
+            <a:pPr algn="l">
+              <a:lnSpc>
+                <a:spcPct val="115000"/>
+              </a:lnSpc>
+            </a:pPr>
+            <a:r>
+              <a:rPr sz="1500" b="1" i="0">
                 <a:solidFill>
-                  <a:srgbClr val="8A8477"/>
+                  <a:srgbClr val="EDE6D6"/>
                 </a:solidFill>
                 <a:latin typeface="Segoe UI"/>
               </a:rPr>
-              <a:t>   ·   Team: [Name 1] · [Name 2] · [Name 3]</a:t>
-            </a:r>
-          </a:p>
-        </p:txBody>
-      </p:sp>
-      <p:sp>
-        <p:nvSpPr>
-          <p:cNvPr id="34" name="TextBox 33"/>
+              <a:t>Team Trident</a:t>
+            </a:r>
+            <a:r>
+              <a:rPr sz="1500" b="0" i="0">
+                <a:solidFill>
+                  <a:srgbClr val="B8B1A2"/>
+                </a:solidFill>
+                <a:latin typeface="Segoe UI"/>
+              </a:rPr>
+              <a:t>   Vaibhav Chauhan (U25EV012)  ·  Akash Biswas (U25EV048)  ·  Madhura Saravade (U25EV038)</a:t>
+            </a:r>
+          </a:p>
+        </p:txBody>
+      </p:sp>
+      <p:sp>
+        <p:nvSpPr>
+          <p:cNvPr id="35" name="TextBox 34"/>
           <p:cNvSpPr txBox="1"/>
           <p:nvPr/>
         </p:nvSpPr>
@@ -6330,7 +6447,7 @@
       </p:sp>
       <p:sp>
         <p:nvSpPr>
-          <p:cNvPr id="35" name="TextBox 34"/>
+          <p:cNvPr id="36" name="TextBox 35"/>
           <p:cNvSpPr txBox="1"/>
           <p:nvPr/>
         </p:nvSpPr>

</xml_diff>